<commit_message>
feat: sinkronisasi editan slide ke PPTX final
</commit_message>
<xml_diff>
--- a/Presentasi_UTS_SI-SAPRAS_JTIK_FotoWawancara.pptx
+++ b/Presentasi_UTS_SI-SAPRAS_JTIK_FotoWawancara.pptx
@@ -3547,7 +3547,7 @@
               </a:defRPr>
             </a:pPr>
             <a:r>
-              <a:t>Tim Pengembang (Kelompok 2 HCI - Teknik Komputer):</a:t>
+              <a:t>Tim Pengembang (Kelompok 2 HCI):</a:t>
             </a:r>
             <a:br/>
             <a:r>
@@ -4639,7 +4639,7 @@
               </a:defRPr>
             </a:pPr>
             <a:r>
-              <a:t>https://sisapras.jtik.unm.ac.id/analisis-data</a:t>
+              <a:t>https://sisapras.jtik.unm.ac.id/closing</a:t>
             </a:r>
           </a:p>
         </p:txBody>
@@ -4694,7 +4694,7 @@
               </a:defRPr>
             </a:pPr>
             <a:r>
-              <a:t>ANALISIS</a:t>
+              <a:t>PENUTUP</a:t>
             </a:r>
           </a:p>
         </p:txBody>
@@ -4730,7 +4730,7 @@
               </a:defRPr>
             </a:pPr>
             <a:r>
-              <a:t>✦ BAB III — TEKNIK ANALISIS DATA</a:t>
+              <a:t>✦ BAB III — PENUTUP</a:t>
             </a:r>
           </a:p>
           <a:p>
@@ -4743,20 +4743,7 @@
               </a:defRPr>
             </a:pPr>
             <a:r>
-              <a:t>3.5 Analisis Data &amp; Sesi Diskusi Tanya Jawab</a:t>
-            </a:r>
-          </a:p>
-          <a:p>
-            <a:pPr>
-              <a:defRPr sz="1100">
-                <a:solidFill>
-                  <a:srgbClr val="475569"/>
-                </a:solidFill>
-                <a:latin typeface="Arial"/>
-              </a:defRPr>
-            </a:pPr>
-            <a:r>
-              <a:t>Tahapan pengelompokan temuan wawancara menjadi spesifikasi kebutuhan antarmuka</a:t>
+              <a:t>Sesi Tanya Jawab</a:t>
             </a:r>
           </a:p>
         </p:txBody>
@@ -6959,7 +6946,7 @@
         <p:spPr>
           <a:xfrm>
             <a:off x="822960" y="2011680"/>
-            <a:ext cx="5120640" cy="3017520"/>
+            <a:ext cx="5120640" cy="4114800"/>
           </a:xfrm>
           <a:prstGeom prst="roundRect">
             <a:avLst/>
@@ -7004,7 +6991,7 @@
         <p:spPr>
           <a:xfrm>
             <a:off x="1005840" y="2148840"/>
-            <a:ext cx="4754880" cy="2743200"/>
+            <a:ext cx="4754880" cy="3840480"/>
           </a:xfrm>
           <a:prstGeom prst="rect">
             <a:avLst/>
@@ -7043,14 +7030,17 @@
               <a:t>• Mencari informasi barang, jumlah, dan ketersediaan stok.</a:t>
             </a:r>
             <a:br/>
+            <a:br/>
             <a:r>
               <a:t>• Mengetahui lokasi barang di Bengkel IT, Lab, dan Ruang Admin.</a:t>
             </a:r>
             <a:br/>
+            <a:br/>
             <a:r>
               <a:t>• Alur pengajuan peminjaman, pelaporan penggunaan, dan pengembalian.</a:t>
             </a:r>
             <a:br/>
+            <a:br/>
             <a:r>
               <a:t>• Informasi inventaris yang berkaitan dengan proses tersebut.</a:t>
             </a:r>
@@ -7066,7 +7056,7 @@
         <p:spPr>
           <a:xfrm>
             <a:off x="6217920" y="2011680"/>
-            <a:ext cx="5120640" cy="3017520"/>
+            <a:ext cx="5120640" cy="4114800"/>
           </a:xfrm>
           <a:prstGeom prst="roundRect">
             <a:avLst/>
@@ -7111,7 +7101,7 @@
         <p:spPr>
           <a:xfrm>
             <a:off x="6400800" y="2148840"/>
-            <a:ext cx="4754880" cy="2743200"/>
+            <a:ext cx="4754880" cy="3840480"/>
           </a:xfrm>
           <a:prstGeom prst="rect">
             <a:avLst/>
@@ -7150,110 +7140,19 @@
               <a:t>• Dashboard perekaman aktivitas laboratorium otomatis.</a:t>
             </a:r>
             <a:br/>
+            <a:br/>
             <a:r>
               <a:t>• Sensor penggunaan listrik di laboratorium.</a:t>
             </a:r>
             <a:br/>
+            <a:br/>
             <a:r>
               <a:t>• Unit usaha untuk penyewaan barang komersial.</a:t>
             </a:r>
             <a:br/>
+            <a:br/>
             <a:r>
               <a:t>• Pembuatan kode program, basis data, dan implementasi sistem langsung.</a:t>
-            </a:r>
-          </a:p>
-        </p:txBody>
-      </p:sp>
-      <p:sp>
-        <p:nvSpPr>
-          <p:cNvPr id="15" name="Rounded Rectangle 14"/>
-          <p:cNvSpPr/>
-          <p:nvPr/>
-        </p:nvSpPr>
-        <p:spPr>
-          <a:xfrm>
-            <a:off x="822960" y="5257800"/>
-            <a:ext cx="10515600" cy="914400"/>
-          </a:xfrm>
-          <a:prstGeom prst="roundRect">
-            <a:avLst/>
-          </a:prstGeom>
-          <a:solidFill>
-            <a:srgbClr val="FEF08A"/>
-          </a:solidFill>
-          <a:ln w="25400">
-            <a:solidFill>
-              <a:srgbClr val="0F172A"/>
-            </a:solidFill>
-          </a:ln>
-        </p:spPr>
-        <p:style>
-          <a:lnRef idx="1">
-            <a:schemeClr val="accent1"/>
-          </a:lnRef>
-          <a:fillRef idx="3">
-            <a:schemeClr val="accent1"/>
-          </a:fillRef>
-          <a:effectRef idx="2">
-            <a:schemeClr val="accent1"/>
-          </a:effectRef>
-          <a:fontRef idx="minor">
-            <a:schemeClr val="lt1"/>
-          </a:fontRef>
-        </p:style>
-        <p:txBody>
-          <a:bodyPr rtlCol="0" anchor="ctr"/>
-          <a:lstStyle/>
-          <a:p>
-            <a:pPr algn="ctr"/>
-          </a:p>
-        </p:txBody>
-      </p:sp>
-      <p:sp>
-        <p:nvSpPr>
-          <p:cNvPr id="16" name="TextBox 15"/>
-          <p:cNvSpPr txBox="1"/>
-          <p:nvPr/>
-        </p:nvSpPr>
-        <p:spPr>
-          <a:xfrm>
-            <a:off x="1005840" y="5349240"/>
-            <a:ext cx="10149840" cy="731520"/>
-          </a:xfrm>
-          <a:prstGeom prst="rect">
-            <a:avLst/>
-          </a:prstGeom>
-          <a:noFill/>
-        </p:spPr>
-        <p:txBody>
-          <a:bodyPr wrap="square">
-            <a:spAutoFit/>
-          </a:bodyPr>
-          <a:lstStyle/>
-          <a:p>
-            <a:pPr>
-              <a:defRPr sz="1000" b="1">
-                <a:solidFill>
-                  <a:srgbClr val="0F172A"/>
-                </a:solidFill>
-                <a:latin typeface="Arial"/>
-              </a:defRPr>
-            </a:pPr>
-            <a:r>
-              <a:t>📌 PERNYATAAN TEGAS BENTUK LUARAN PENELITIAN:</a:t>
-            </a:r>
-          </a:p>
-          <a:p>
-            <a:pPr>
-              <a:defRPr sz="1100">
-                <a:solidFill>
-                  <a:srgbClr val="0F172A"/>
-                </a:solidFill>
-                <a:latin typeface="Arial"/>
-              </a:defRPr>
-            </a:pPr>
-            <a:r>
-              <a:t>Keluaran murni berupa dokumen perancangan antarmuka pengguna SI-SAPRAS JTIK (analisis kebutuhan, struktur tugas HTA, alur pengguna, dan prototipe UI).</a:t>
             </a:r>
           </a:p>
         </p:txBody>

</xml_diff>

<commit_message>
fix: tetapkan pendekatan murni HCD (bukan UCD) dan hapus observasi (hanya wawancara mendalam)
</commit_message>
<xml_diff>
--- a/Presentasi_UTS_SI-SAPRAS_JTIK_FotoWawancara.pptx
+++ b/Presentasi_UTS_SI-SAPRAS_JTIK_FotoWawancara.pptx
@@ -3533,7 +3533,7 @@
               </a:defRPr>
             </a:pPr>
             <a:r>
-              <a:t>Rancang Bangun Antarmuka Pengguna Sistem Informasi Peminjaman Sarana Prasarana di JTIK Berbasis User-Centered Design (UCD)</a:t>
+              <a:t>Rancang Bangun Antarmuka Pengguna Sistem Informasi Peminjaman Sarana Prasarana di JTIK Berbasis Human-Centered Design (HCD)</a:t>
             </a:r>
           </a:p>
           <a:p>
@@ -8298,7 +8298,7 @@
               </a:defRPr>
             </a:pPr>
             <a:r>
-              <a:t>Perancangan Berpusat pada Manusia (HCD / UCD)</a:t>
+              <a:t>Perancangan Berpusat pada Manusia (Human-Centered Design / HCD)</a:t>
             </a:r>
           </a:p>
           <a:p>
@@ -10707,7 +10707,7 @@
               </a:defRPr>
             </a:pPr>
             <a:r>
-              <a:t>Pengumpulan data empiris di Bengkel IT dan Laboratorium JTIK FT UNM</a:t>
+              <a:t>Pengumpulan data empiris melalui wawancara mendalam di Bengkel IT JTIK FT UNM</a:t>
             </a:r>
           </a:p>
         </p:txBody>
@@ -10824,7 +10824,7 @@
             </a:r>
             <a:br/>
             <a:r>
-              <a:t>Pengumpulan data, analisis kebutuhan, penyusunan HTA &amp; User Flow, serta perancangan antarmuka.</a:t>
+              <a:t>Pengumpulan data wawancara, analisis kebutuhan, penyusunan HTA &amp; User Flow, serta perancangan antarmuka.</a:t>
             </a:r>
           </a:p>
         </p:txBody>
@@ -10905,13 +10905,13 @@
               </a:defRPr>
             </a:pPr>
             <a:r>
-              <a:t>2. Teknik Pengumpulan</a:t>
+              <a:t>2. Teknik Pengumpulan Data</a:t>
             </a:r>
           </a:p>
           <a:p>
             <a:br/>
             <a:pPr>
-              <a:defRPr sz="1100">
+              <a:defRPr sz="1050">
                 <a:solidFill>
                   <a:srgbClr val="0F172A"/>
                 </a:solidFill>
@@ -10919,20 +10919,29 @@
               </a:defRPr>
             </a:pPr>
             <a:r>
-              <a:t>• Wawancara:</a:t>
-            </a:r>
-            <a:br/>
-            <a:r>
-              <a:t>Memperoleh info langsung proses pengelolaan sarpras dan kendala yang dihadapi.</a:t>
-            </a:r>
-            <a:br/>
-            <a:br/>
-            <a:r>
-              <a:t>• Observasi:</a:t>
-            </a:r>
-            <a:br/>
-            <a:r>
-              <a:t>Pengamatan langsung jenis &amp; jumlah barang, lokasi rak, cara ambil barang, pencatatan buku, serta kondisi kekurangan kursi kelas.</a:t>
+              <a:t>• Wawancara Mendalam:</a:t>
+            </a:r>
+            <a:br/>
+            <a:r>
+              <a:t>Wawancara langsung untuk menggali prosedur operasional dan hambatan nyata dalam pengelolaan sarpras JTIK.</a:t>
+            </a:r>
+            <a:br/>
+            <a:br/>
+            <a:r>
+              <a:t>• Fokus Penggalian:</a:t>
+            </a:r>
+            <a:br/>
+            <a:r>
+              <a:t>Kendala pencatatan buku konvensional, sebaran alat di 3 ruangan, fenomena bangku kelas, dan verifikasi bebas sarpras.</a:t>
+            </a:r>
+            <a:br/>
+            <a:br/>
+            <a:r>
+              <a:t>• Tujuan Data:</a:t>
+            </a:r>
+            <a:br/>
+            <a:r>
+              <a:t>Menjadi landasan penyusunan HTA, User Flow, serta arsitektur solusi sistem informasi.</a:t>
             </a:r>
           </a:p>
         </p:txBody>

</xml_diff>

<commit_message>
fix: rapikan Card 3.2 Slide 8 persis sesuai tangkapan layar (hanya wawancara mendalam tanpa box tambahan)
</commit_message>
<xml_diff>
--- a/Presentasi_UTS_SI-SAPRAS_JTIK_FotoWawancara.pptx
+++ b/Presentasi_UTS_SI-SAPRAS_JTIK_FotoWawancara.pptx
@@ -10905,13 +10905,13 @@
               </a:defRPr>
             </a:pPr>
             <a:r>
-              <a:t>2. Teknik Pengumpulan Data</a:t>
+              <a:t>2. Teknik Pengumpulan</a:t>
             </a:r>
           </a:p>
           <a:p>
             <a:br/>
             <a:pPr>
-              <a:defRPr sz="1050">
+              <a:defRPr sz="1100">
                 <a:solidFill>
                   <a:srgbClr val="0F172A"/>
                 </a:solidFill>
@@ -10919,29 +10919,16 @@
               </a:defRPr>
             </a:pPr>
             <a:r>
+              <a:t>Wawancara Mendalam</a:t>
+            </a:r>
+            <a:br/>
+            <a:br/>
+            <a:r>
               <a:t>• Wawancara Mendalam:</a:t>
             </a:r>
             <a:br/>
             <a:r>
-              <a:t>Wawancara langsung untuk menggali prosedur operasional dan hambatan nyata dalam pengelolaan sarpras JTIK.</a:t>
-            </a:r>
-            <a:br/>
-            <a:br/>
-            <a:r>
-              <a:t>• Fokus Penggalian:</a:t>
-            </a:r>
-            <a:br/>
-            <a:r>
-              <a:t>Kendala pencatatan buku konvensional, sebaran alat di 3 ruangan, fenomena bangku kelas, dan verifikasi bebas sarpras.</a:t>
-            </a:r>
-            <a:br/>
-            <a:br/>
-            <a:r>
-              <a:t>• Tujuan Data:</a:t>
-            </a:r>
-            <a:br/>
-            <a:r>
-              <a:t>Menjadi landasan penyusunan HTA, User Flow, serta arsitektur solusi sistem informasi.</a:t>
+              <a:t>Menggali alur pengelolaan, kendala pencatatan buku konvensional, sebaran alat laboratorium, dan kebutuhan bukti bebas pinjam.</a:t>
             </a:r>
           </a:p>
         </p:txBody>

</xml_diff>

<commit_message>
fix: ganti seluruh istilah HCD menjadi User-Centered Design (UCD) sesuai instruksi
</commit_message>
<xml_diff>
--- a/Presentasi_UTS_SI-SAPRAS_JTIK_FotoWawancara.pptx
+++ b/Presentasi_UTS_SI-SAPRAS_JTIK_FotoWawancara.pptx
@@ -3533,7 +3533,7 @@
               </a:defRPr>
             </a:pPr>
             <a:r>
-              <a:t>Rancang Bangun Antarmuka Pengguna Sistem Informasi Peminjaman Sarana Prasarana di JTIK Berbasis Human-Centered Design (HCD)</a:t>
+              <a:t>Rancang Bangun Antarmuka Pengguna Sistem Informasi Peminjaman Sarana Prasarana di JTIK Berbasis User-Centered Design (UCD)</a:t>
             </a:r>
           </a:p>
           <a:p>
@@ -8194,7 +8194,7 @@
               </a:defRPr>
             </a:pPr>
             <a:r>
-              <a:t>https://sisapras.jtik.unm.ac.id/metode-hcd</a:t>
+              <a:t>https://sisapras.jtik.unm.ac.id/metode-ucd</a:t>
             </a:r>
           </a:p>
         </p:txBody>
@@ -8298,7 +8298,7 @@
               </a:defRPr>
             </a:pPr>
             <a:r>
-              <a:t>Perancangan Berpusat pada Manusia (Human-Centered Design / HCD)</a:t>
+              <a:t>Perancangan Berpusat pada Pengguna (User-Centered Design / UCD)</a:t>
             </a:r>
           </a:p>
           <a:p>
@@ -10806,7 +10806,7 @@
             </a:r>
             <a:br/>
             <a:r>
-              <a:t>Human-Centered Design (HCD).</a:t>
+              <a:t>User-Centered Design (UCD).</a:t>
             </a:r>
             <a:br/>
             <a:br/>

</xml_diff>